<commit_message>
Audit numbers, refresh charts and tidy repository layout
- Fix the Pareto claim: 19 of 294 SKUs pass 80% of volume (80.3%), not 20 (81.4%),
  in the README, deck and Power BI subtitle
- Restyle the six analysis charts with one palette and font, remove overlapping labels,
  colour billers by failure rate instead of failure share
- Rename data files to descriptive names, drop the duplicate XLSX and the unused data.json
- Add src/build_database.py so the SQLite database can be rebuilt from the CSV
- Move the Power BI preview renderer into src/ and fix its axis ticks
- Add data/README.md (data dictionary), module docstrings and a reproduce section

Co-Authored-By: Claude Opus 5.5 (1M context) <noreply@anthropic.com>
Claude-Session: https://claude.ai/code/session_01AzYXhUBDwPdTQFMjVpXnAp
</commit_message>
<xml_diff>
--- a/presentations/Fintech_PPOB_Transaction_Operations_Analytics.pptx
+++ b/presentations/Fintech_PPOB_Transaction_Operations_Analytics.pptx
@@ -3882,7 +3882,7 @@
         <p:spPr>
           <a:xfrm>
             <a:off x="914400" y="2834640"/>
-            <a:ext cx="3141041" cy="3566160"/>
+            <a:ext cx="3208917" cy="3566160"/>
           </a:xfrm>
           <a:prstGeom prst="rect">
             <a:avLst/>
@@ -4152,7 +4152,7 @@
         <p:spPr>
           <a:xfrm>
             <a:off x="731520" y="1371600"/>
-            <a:ext cx="5943600" cy="2946827"/>
+            <a:ext cx="5943600" cy="3362720"/>
           </a:xfrm>
           <a:prstGeom prst="rect">
             <a:avLst/>
@@ -4252,7 +4252,7 @@
               </a:defRPr>
             </a:pPr>
             <a:r>
-              <a:t>• Heavy Pareto Skew: The top 5 SKUs carry 57.3% of volume (181.3k tx). It takes 20 SKUs to pass 80% (81.4%).</a:t>
+              <a:t>• Heavy Pareto Skew: The top 5 SKUs carry 57.3% of volume (181.3k tx). 19 of 294 SKUs are enough to pass 80% (80.3%).</a:t>
             </a:r>
           </a:p>
           <a:p>
@@ -4422,7 +4422,7 @@
         <p:spPr>
           <a:xfrm>
             <a:off x="731520" y="1371600"/>
-            <a:ext cx="5669280" cy="3378662"/>
+            <a:ext cx="5669280" cy="3869458"/>
           </a:xfrm>
           <a:prstGeom prst="rect">
             <a:avLst/>
@@ -4446,7 +4446,7 @@
         <p:spPr>
           <a:xfrm>
             <a:off x="6492240" y="1371600"/>
-            <a:ext cx="4937760" cy="2448133"/>
+            <a:ext cx="4937760" cy="2712832"/>
           </a:xfrm>
           <a:prstGeom prst="rect">
             <a:avLst/>
@@ -4657,7 +4657,7 @@
         <p:spPr>
           <a:xfrm>
             <a:off x="731520" y="1371600"/>
-            <a:ext cx="7315200" cy="3247107"/>
+            <a:ext cx="7315200" cy="3851877"/>
           </a:xfrm>
           <a:prstGeom prst="rect">
             <a:avLst/>
@@ -4927,7 +4927,7 @@
         <p:spPr>
           <a:xfrm>
             <a:off x="731520" y="1371600"/>
-            <a:ext cx="6858000" cy="3136605"/>
+            <a:ext cx="6858000" cy="3574135"/>
           </a:xfrm>
           <a:prstGeom prst="rect">
             <a:avLst/>

</xml_diff>

<commit_message>
Audit numbers, refresh charts and tidy repository layout (#2)
- Fix the Pareto claim: 19 of 294 SKUs pass 80% of volume (80.3%), not 20 (81.4%),
  in the README, deck and Power BI subtitle
- Restyle the six analysis charts with one palette and font, remove overlapping labels,
  colour billers by failure rate instead of failure share
- Rename data files to descriptive names, drop the duplicate XLSX and the unused data.json
- Add src/build_database.py so the SQLite database can be rebuilt from the CSV
- Move the Power BI preview renderer into src/ and fix its axis ticks
- Add data/README.md (data dictionary), module docstrings and a reproduce section


Claude-Session: https://claude.ai/code/session_01AzYXhUBDwPdTQFMjVpXnAp

Co-authored-by: Claude <noreply@anthropic.com>
</commit_message>
<xml_diff>
--- a/presentations/Fintech_PPOB_Transaction_Operations_Analytics.pptx
+++ b/presentations/Fintech_PPOB_Transaction_Operations_Analytics.pptx
@@ -3882,7 +3882,7 @@
         <p:spPr>
           <a:xfrm>
             <a:off x="914400" y="2834640"/>
-            <a:ext cx="3141041" cy="3566160"/>
+            <a:ext cx="3208917" cy="3566160"/>
           </a:xfrm>
           <a:prstGeom prst="rect">
             <a:avLst/>
@@ -4152,7 +4152,7 @@
         <p:spPr>
           <a:xfrm>
             <a:off x="731520" y="1371600"/>
-            <a:ext cx="5943600" cy="2946827"/>
+            <a:ext cx="5943600" cy="3362720"/>
           </a:xfrm>
           <a:prstGeom prst="rect">
             <a:avLst/>
@@ -4252,7 +4252,7 @@
               </a:defRPr>
             </a:pPr>
             <a:r>
-              <a:t>• Heavy Pareto Skew: The top 5 SKUs carry 57.3% of volume (181.3k tx). It takes 20 SKUs to pass 80% (81.4%).</a:t>
+              <a:t>• Heavy Pareto Skew: The top 5 SKUs carry 57.3% of volume (181.3k tx). 19 of 294 SKUs are enough to pass 80% (80.3%).</a:t>
             </a:r>
           </a:p>
           <a:p>
@@ -4422,7 +4422,7 @@
         <p:spPr>
           <a:xfrm>
             <a:off x="731520" y="1371600"/>
-            <a:ext cx="5669280" cy="3378662"/>
+            <a:ext cx="5669280" cy="3869458"/>
           </a:xfrm>
           <a:prstGeom prst="rect">
             <a:avLst/>
@@ -4446,7 +4446,7 @@
         <p:spPr>
           <a:xfrm>
             <a:off x="6492240" y="1371600"/>
-            <a:ext cx="4937760" cy="2448133"/>
+            <a:ext cx="4937760" cy="2712832"/>
           </a:xfrm>
           <a:prstGeom prst="rect">
             <a:avLst/>
@@ -4657,7 +4657,7 @@
         <p:spPr>
           <a:xfrm>
             <a:off x="731520" y="1371600"/>
-            <a:ext cx="7315200" cy="3247107"/>
+            <a:ext cx="7315200" cy="3851877"/>
           </a:xfrm>
           <a:prstGeom prst="rect">
             <a:avLst/>
@@ -4927,7 +4927,7 @@
         <p:spPr>
           <a:xfrm>
             <a:off x="731520" y="1371600"/>
-            <a:ext cx="6858000" cy="3136605"/>
+            <a:ext cx="6858000" cy="3574135"/>
           </a:xfrm>
           <a:prstGeom prst="rect">
             <a:avLst/>

</xml_diff>